<commit_message>
Semester 1 Week 02: learning path, Q4 Excel answer, notebook and slide corrections
- README: before-you-start, ordered steps, outcomes, next; key answers; staff notes
- Notebooks: correct the "negatives" comments (wrong in Q6 Part A), fval note,
  Q6 Part C label, binding constraints, Part C with the cost objective; tidy
- Lecture .pptx: slides 12, 15, 18, 19, 24, 25, 26
- Answers .docx: Q2 matrix form, Q5c heading and whole-number note, 6b typo,
  notebook names, 6c cost, blank last page
- Tutorial .docx: replace the Spyder line
- New 4 Tutorial Answers/Q4 LP with Excel Solver.xlsx

Co-Authored-By: Claude Opus 5.5 <noreply@anthropic.com>
Claude-Session: https://claude.ai/code/session_01RLyQJKCaXwMcJypJVCDKWB
</commit_message>
<xml_diff>
--- a/content/Lectures/Semester 1/Week 02 - Linear Programming 1/5 Source Files/Week 2 - Linear Programming 1.pptx
+++ b/content/Lectures/Semester 1/Week 02 - Linear Programming 1/5 Source Files/Week 2 - Linear Programming 1.pptx
@@ -5021,7 +5021,7 @@
                         <a:rPr lang="en-GB" b="0" i="1" smtClean="0">
                           <a:latin typeface="Cambria Math" panose="02040503050406030204" pitchFamily="18" charset="0"/>
                         </a:rPr>
-                        <m:t>=£277.72</m:t>
+                        <m:t>=£277.71</m:t>
                       </m:r>
                     </m:oMath>
                   </m:oMathPara>
@@ -8040,7 +8040,7 @@
                           </a:solidFill>
                           <a:latin typeface="Cambria Math" panose="02040503050406030204" pitchFamily="18" charset="0"/>
                         </a:rPr>
-                        <m:t>=4⋅10.29</m:t>
+                        <m:t>≈4⋅10.29</m:t>
                       </m:r>
                     </m:oMath>
                   </m:oMathPara>
@@ -10569,7 +10569,7 @@
                 </a14:m>
                 <a:r>
                   <a:rPr lang="en-GB" b="0" dirty="0"/>
-                  <a:t>. Thus </a:t>
+                  <a:t> from (0, 72) to (48, 0). Thus </a:t>
                 </a:r>
                 <a14:m>
                   <m:oMath xmlns:m="http://schemas.openxmlformats.org/officeDocument/2006/math">
@@ -11613,7 +11613,7 @@
             </a:pPr>
             <a:r>
               <a:rPr lang="en-GB" dirty="0"/>
-              <a:t>Optimal solution always contained at a boundary, however may lie on the boundary</a:t>
+              <a:t>An optimal solution always lies on the boundary of the feasible region: at a vertex, or along a whole edge (infinitely many solutions).</a:t>
             </a:r>
           </a:p>
           <a:p>
@@ -11628,7 +11628,7 @@
             </a:pPr>
             <a:r>
               <a:rPr lang="en-GB" dirty="0"/>
-              <a:t>Optimal solution always exists at a vertex, these are known as </a:t>
+              <a:t>If an optimal solution exists, one is always at a vertex. The vertices are known as </a:t>
             </a:r>
             <a:r>
               <a:rPr lang="en-GB" u="sng" dirty="0"/>
@@ -18842,7 +18842,7 @@
           <a:p>
             <a:r>
               <a:rPr lang="en-GB" dirty="0"/>
-              <a:t>maximum and minimum equivalence</a:t>
+              <a:t>Maximum and minimum equivalence</a:t>
             </a:r>
           </a:p>
         </p:txBody>
@@ -20245,7 +20245,7 @@
               <a:rPr lang="en-GB" dirty="0">
                 <a:hlinkClick r:id="rId3"/>
               </a:rPr>
-              <a:t> — SciPy v1.11.3 Manual</a:t>
+              <a:t> — SciPy documentation</a:t>
             </a:r>
             <a:endParaRPr lang="en-GB" dirty="0"/>
           </a:p>
@@ -20450,7 +20450,7 @@
             </a:pPr>
             <a:r>
               <a:rPr lang="en-GB" dirty="0"/>
-              <a:t>We will use a friendlier way to express this next week, however it important to:</a:t>
+              <a:t>We will use a friendlier way to express this next week, however it is important to:</a:t>
             </a:r>
           </a:p>
           <a:p>

</xml_diff>

<commit_message>
Optional, your side: open the .pptx in PowerPoint, click into the edited text boxes on slides 11, 12, 15 and 18, and save. This is the same step you did for Week 01. The reason is under question 3.
</commit_message>
<xml_diff>
--- a/content/Lectures/Semester 1/Week 02 - Linear Programming 1/5 Source Files/Week 2 - Linear Programming 1.pptx
+++ b/content/Lectures/Semester 1/Week 02 - Linear Programming 1/5 Source Files/Week 2 - Linear Programming 1.pptx
@@ -154,6 +154,38 @@
 
 <file path=ppt/changesInfos/changesInfo1.xml><?xml version="1.0" encoding="utf-8"?>
 <pc:chgInfo xmlns:a="http://schemas.openxmlformats.org/drawingml/2006/main" xmlns:r="http://schemas.openxmlformats.org/officeDocument/2006/relationships" xmlns:ac="http://schemas.microsoft.com/office/drawing/2013/main/command" xmlns:pc="http://schemas.microsoft.com/office/powerpoint/2013/main/command">
+  <pc:docChgLst>
+    <pc:chgData name="Sam O'Neill" userId="cb323814-a42a-4cfe-bc74-03f595e56f6e" providerId="ADAL" clId="{FC573C1E-5364-4385-B41B-4E798FCD684A}"/>
+    <pc:docChg chg="custSel modSld">
+      <pc:chgData name="Sam O'Neill" userId="cb323814-a42a-4cfe-bc74-03f595e56f6e" providerId="ADAL" clId="{FC573C1E-5364-4385-B41B-4E798FCD684A}" dt="2023-10-02T09:01:02.828" v="6" actId="14100"/>
+      <pc:docMkLst>
+        <pc:docMk/>
+      </pc:docMkLst>
+      <pc:sldChg chg="addSp delSp modSp mod">
+        <pc:chgData name="Sam O'Neill" userId="cb323814-a42a-4cfe-bc74-03f595e56f6e" providerId="ADAL" clId="{FC573C1E-5364-4385-B41B-4E798FCD684A}" dt="2023-10-02T09:01:02.828" v="6" actId="14100"/>
+        <pc:sldMkLst>
+          <pc:docMk/>
+          <pc:sldMk cId="2837434748" sldId="281"/>
+        </pc:sldMkLst>
+      </pc:sldChg>
+    </pc:docChg>
+  </pc:docChgLst>
+  <pc:docChgLst>
+    <pc:chgData name="Sam O'Neill" userId="cb323814-a42a-4cfe-bc74-03f595e56f6e" providerId="ADAL" clId="{FE101BF0-67F3-4B44-8042-2748916B529A}"/>
+    <pc:docChg chg="custSel modSld">
+      <pc:chgData name="Sam O'Neill" userId="cb323814-a42a-4cfe-bc74-03f595e56f6e" providerId="ADAL" clId="{FE101BF0-67F3-4B44-8042-2748916B529A}" dt="2023-10-02T10:53:03.337" v="4" actId="1076"/>
+      <pc:docMkLst>
+        <pc:docMk/>
+      </pc:docMkLst>
+      <pc:sldChg chg="addSp delSp modSp mod">
+        <pc:chgData name="Sam O'Neill" userId="cb323814-a42a-4cfe-bc74-03f595e56f6e" providerId="ADAL" clId="{FE101BF0-67F3-4B44-8042-2748916B529A}" dt="2023-10-02T10:53:03.337" v="4" actId="1076"/>
+        <pc:sldMkLst>
+          <pc:docMk/>
+          <pc:sldMk cId="2837434748" sldId="281"/>
+        </pc:sldMkLst>
+      </pc:sldChg>
+    </pc:docChg>
+  </pc:docChgLst>
   <pc:docChgLst>
     <pc:chgData name="Sam O'Neill" userId="cb323814-a42a-4cfe-bc74-03f595e56f6e" providerId="ADAL" clId="{E5DEC410-C6B0-4C99-8A50-0FAAAFFEC6E4}"/>
     <pc:docChg chg="undo custSel modSld modMainMaster">
@@ -452,38 +484,6 @@
       </pc:sldMasterChg>
     </pc:docChg>
   </pc:docChgLst>
-  <pc:docChgLst>
-    <pc:chgData name="Sam O'Neill" userId="cb323814-a42a-4cfe-bc74-03f595e56f6e" providerId="ADAL" clId="{FE101BF0-67F3-4B44-8042-2748916B529A}"/>
-    <pc:docChg chg="custSel modSld">
-      <pc:chgData name="Sam O'Neill" userId="cb323814-a42a-4cfe-bc74-03f595e56f6e" providerId="ADAL" clId="{FE101BF0-67F3-4B44-8042-2748916B529A}" dt="2023-10-02T10:53:03.337" v="4" actId="1076"/>
-      <pc:docMkLst>
-        <pc:docMk/>
-      </pc:docMkLst>
-      <pc:sldChg chg="addSp delSp modSp mod">
-        <pc:chgData name="Sam O'Neill" userId="cb323814-a42a-4cfe-bc74-03f595e56f6e" providerId="ADAL" clId="{FE101BF0-67F3-4B44-8042-2748916B529A}" dt="2023-10-02T10:53:03.337" v="4" actId="1076"/>
-        <pc:sldMkLst>
-          <pc:docMk/>
-          <pc:sldMk cId="2837434748" sldId="281"/>
-        </pc:sldMkLst>
-      </pc:sldChg>
-    </pc:docChg>
-  </pc:docChgLst>
-  <pc:docChgLst>
-    <pc:chgData name="Sam O'Neill" userId="cb323814-a42a-4cfe-bc74-03f595e56f6e" providerId="ADAL" clId="{FC573C1E-5364-4385-B41B-4E798FCD684A}"/>
-    <pc:docChg chg="custSel modSld">
-      <pc:chgData name="Sam O'Neill" userId="cb323814-a42a-4cfe-bc74-03f595e56f6e" providerId="ADAL" clId="{FC573C1E-5364-4385-B41B-4E798FCD684A}" dt="2023-10-02T09:01:02.828" v="6" actId="14100"/>
-      <pc:docMkLst>
-        <pc:docMk/>
-      </pc:docMkLst>
-      <pc:sldChg chg="addSp delSp modSp mod">
-        <pc:chgData name="Sam O'Neill" userId="cb323814-a42a-4cfe-bc74-03f595e56f6e" providerId="ADAL" clId="{FC573C1E-5364-4385-B41B-4E798FCD684A}" dt="2023-10-02T09:01:02.828" v="6" actId="14100"/>
-        <pc:sldMkLst>
-          <pc:docMk/>
-          <pc:sldMk cId="2837434748" sldId="281"/>
-        </pc:sldMkLst>
-      </pc:sldChg>
-    </pc:docChg>
-  </pc:docChgLst>
 </pc:chgInfo>
 </file>
 
@@ -636,7 +636,7 @@
           <a:p>
             <a:fld id="{56A039F1-953F-4A39-846E-4A181A4AE2B1}" type="datetimeFigureOut">
               <a:rPr lang="en-GB" smtClean="0"/>
-              <a:t>01/10/2025</a:t>
+              <a:t>17/10/2026</a:t>
             </a:fld>
             <a:endParaRPr lang="en-GB"/>
           </a:p>
@@ -836,7 +836,7 @@
           <a:p>
             <a:fld id="{56A039F1-953F-4A39-846E-4A181A4AE2B1}" type="datetimeFigureOut">
               <a:rPr lang="en-GB" smtClean="0"/>
-              <a:t>01/10/2025</a:t>
+              <a:t>17/10/2026</a:t>
             </a:fld>
             <a:endParaRPr lang="en-GB"/>
           </a:p>
@@ -1046,7 +1046,7 @@
           <a:p>
             <a:fld id="{56A039F1-953F-4A39-846E-4A181A4AE2B1}" type="datetimeFigureOut">
               <a:rPr lang="en-GB" smtClean="0"/>
-              <a:t>01/10/2025</a:t>
+              <a:t>17/10/2026</a:t>
             </a:fld>
             <a:endParaRPr lang="en-GB"/>
           </a:p>
@@ -1246,7 +1246,7 @@
           <a:p>
             <a:fld id="{56A039F1-953F-4A39-846E-4A181A4AE2B1}" type="datetimeFigureOut">
               <a:rPr lang="en-GB" smtClean="0"/>
-              <a:t>01/10/2025</a:t>
+              <a:t>17/10/2026</a:t>
             </a:fld>
             <a:endParaRPr lang="en-GB"/>
           </a:p>
@@ -1522,7 +1522,7 @@
           <a:p>
             <a:fld id="{56A039F1-953F-4A39-846E-4A181A4AE2B1}" type="datetimeFigureOut">
               <a:rPr lang="en-GB" smtClean="0"/>
-              <a:t>01/10/2025</a:t>
+              <a:t>17/10/2026</a:t>
             </a:fld>
             <a:endParaRPr lang="en-GB"/>
           </a:p>
@@ -1790,7 +1790,7 @@
           <a:p>
             <a:fld id="{56A039F1-953F-4A39-846E-4A181A4AE2B1}" type="datetimeFigureOut">
               <a:rPr lang="en-GB" smtClean="0"/>
-              <a:t>01/10/2025</a:t>
+              <a:t>17/10/2026</a:t>
             </a:fld>
             <a:endParaRPr lang="en-GB"/>
           </a:p>
@@ -2205,7 +2205,7 @@
           <a:p>
             <a:fld id="{56A039F1-953F-4A39-846E-4A181A4AE2B1}" type="datetimeFigureOut">
               <a:rPr lang="en-GB" smtClean="0"/>
-              <a:t>01/10/2025</a:t>
+              <a:t>17/10/2026</a:t>
             </a:fld>
             <a:endParaRPr lang="en-GB"/>
           </a:p>
@@ -2347,7 +2347,7 @@
           <a:p>
             <a:fld id="{56A039F1-953F-4A39-846E-4A181A4AE2B1}" type="datetimeFigureOut">
               <a:rPr lang="en-GB" smtClean="0"/>
-              <a:t>01/10/2025</a:t>
+              <a:t>17/10/2026</a:t>
             </a:fld>
             <a:endParaRPr lang="en-GB"/>
           </a:p>
@@ -2460,7 +2460,7 @@
           <a:p>
             <a:fld id="{56A039F1-953F-4A39-846E-4A181A4AE2B1}" type="datetimeFigureOut">
               <a:rPr lang="en-GB" smtClean="0"/>
-              <a:t>01/10/2025</a:t>
+              <a:t>17/10/2026</a:t>
             </a:fld>
             <a:endParaRPr lang="en-GB"/>
           </a:p>
@@ -2773,7 +2773,7 @@
           <a:p>
             <a:fld id="{56A039F1-953F-4A39-846E-4A181A4AE2B1}" type="datetimeFigureOut">
               <a:rPr lang="en-GB" smtClean="0"/>
-              <a:t>01/10/2025</a:t>
+              <a:t>17/10/2026</a:t>
             </a:fld>
             <a:endParaRPr lang="en-GB"/>
           </a:p>
@@ -3062,7 +3062,7 @@
           <a:p>
             <a:fld id="{56A039F1-953F-4A39-846E-4A181A4AE2B1}" type="datetimeFigureOut">
               <a:rPr lang="en-GB" smtClean="0"/>
-              <a:t>01/10/2025</a:t>
+              <a:t>17/10/2026</a:t>
             </a:fld>
             <a:endParaRPr lang="en-GB"/>
           </a:p>
@@ -3305,7 +3305,7 @@
           <a:p>
             <a:fld id="{56A039F1-953F-4A39-846E-4A181A4AE2B1}" type="datetimeFigureOut">
               <a:rPr lang="en-GB" smtClean="0"/>
-              <a:t>01/10/2025</a:t>
+              <a:t>17/10/2026</a:t>
             </a:fld>
             <a:endParaRPr lang="en-GB"/>
           </a:p>
@@ -4794,8 +4794,8 @@
           </a:p>
         </p:txBody>
       </p:sp>
-      <mc:AlternateContent xmlns:mc="http://schemas.openxmlformats.org/markup-compatibility/2006">
-        <mc:Choice xmlns:a14="http://schemas.microsoft.com/office/drawing/2010/main" Requires="a14">
+      <mc:AlternateContent xmlns:mc="http://schemas.openxmlformats.org/markup-compatibility/2006" xmlns:a14="http://schemas.microsoft.com/office/drawing/2010/main">
+        <mc:Choice Requires="a14">
           <p:sp>
             <p:nvSpPr>
               <p:cNvPr id="3" name="Content Placeholder 2">
@@ -5052,7 +5052,7 @@
             </p:txBody>
           </p:sp>
         </mc:Choice>
-        <mc:Fallback>
+        <mc:Fallback xmlns="">
           <p:sp>
             <p:nvSpPr>
               <p:cNvPr id="3" name="Content Placeholder 2">
@@ -5118,7 +5118,7 @@
         </p:blipFill>
         <p:spPr>
           <a:xfrm>
-            <a:off x="6441600" y="1071418"/>
+            <a:off x="6412103" y="1071418"/>
             <a:ext cx="5191125" cy="5219700"/>
           </a:xfrm>
           <a:prstGeom prst="rect">
@@ -8685,8 +8685,8 @@
           </a:p>
         </p:txBody>
       </p:sp>
-      <mc:AlternateContent xmlns:mc="http://schemas.openxmlformats.org/markup-compatibility/2006">
-        <mc:Choice xmlns:a14="http://schemas.microsoft.com/office/drawing/2010/main" Requires="a14">
+      <mc:AlternateContent xmlns:mc="http://schemas.openxmlformats.org/markup-compatibility/2006" xmlns:a14="http://schemas.microsoft.com/office/drawing/2010/main">
+        <mc:Choice Requires="a14">
           <p:sp>
             <p:nvSpPr>
               <p:cNvPr id="3" name="Content Placeholder 2">
@@ -9034,7 +9034,7 @@
             </p:txBody>
           </p:sp>
         </mc:Choice>
-        <mc:Fallback>
+        <mc:Fallback xmlns="">
           <p:sp>
             <p:nvSpPr>
               <p:cNvPr id="3" name="Content Placeholder 2">
@@ -9547,8 +9547,8 @@
           </a:p>
         </p:txBody>
       </p:sp>
-      <mc:AlternateContent xmlns:mc="http://schemas.openxmlformats.org/markup-compatibility/2006">
-        <mc:Choice xmlns:a14="http://schemas.microsoft.com/office/drawing/2010/main" Requires="a14">
+      <mc:AlternateContent xmlns:mc="http://schemas.openxmlformats.org/markup-compatibility/2006" xmlns:a14="http://schemas.microsoft.com/office/drawing/2010/main">
+        <mc:Choice Requires="a14">
           <p:sp>
             <p:nvSpPr>
               <p:cNvPr id="3" name="Content Placeholder 2">
@@ -9824,7 +9824,7 @@
             </p:txBody>
           </p:sp>
         </mc:Choice>
-        <mc:Fallback>
+        <mc:Fallback xmlns="">
           <p:sp>
             <p:nvSpPr>
               <p:cNvPr id="3" name="Content Placeholder 2">
@@ -10221,8 +10221,8 @@
           </a:p>
         </p:txBody>
       </p:sp>
-      <mc:AlternateContent xmlns:mc="http://schemas.openxmlformats.org/markup-compatibility/2006">
-        <mc:Choice xmlns:a14="http://schemas.microsoft.com/office/drawing/2010/main" Requires="a14">
+      <mc:AlternateContent xmlns:mc="http://schemas.openxmlformats.org/markup-compatibility/2006" xmlns:a14="http://schemas.microsoft.com/office/drawing/2010/main">
+        <mc:Choice Requires="a14">
           <p:sp>
             <p:nvSpPr>
               <p:cNvPr id="3" name="Content Placeholder 2">
@@ -10601,18 +10601,13 @@
                 </a:pPr>
                 <a:r>
                   <a:rPr lang="en-GB" dirty="0"/>
-                  <a:t>Note that it still has an optimal solution at </a:t>
+                  <a:t>Note that it still has an optimal solution at a vertex!</a:t>
                 </a:r>
-                <a:r>
-                  <a:rPr lang="en-GB"/>
-                  <a:t>a vertex!</a:t>
-                </a:r>
-                <a:endParaRPr lang="en-GB" dirty="0"/>
               </a:p>
             </p:txBody>
           </p:sp>
         </mc:Choice>
-        <mc:Fallback>
+        <mc:Fallback xmlns="">
           <p:sp>
             <p:nvSpPr>
               <p:cNvPr id="3" name="Content Placeholder 2">
@@ -12050,8 +12045,8 @@
           </a:p>
         </p:txBody>
       </p:sp>
-      <mc:AlternateContent xmlns:mc="http://schemas.openxmlformats.org/markup-compatibility/2006">
-        <mc:Choice xmlns:a14="http://schemas.microsoft.com/office/drawing/2010/main" Requires="a14">
+      <mc:AlternateContent xmlns:mc="http://schemas.openxmlformats.org/markup-compatibility/2006" xmlns:a14="http://schemas.microsoft.com/office/drawing/2010/main">
+        <mc:Choice Requires="a14">
           <p:sp>
             <p:nvSpPr>
               <p:cNvPr id="3" name="Content Placeholder 2">
@@ -12396,7 +12391,7 @@
             </p:txBody>
           </p:sp>
         </mc:Choice>
-        <mc:Fallback>
+        <mc:Fallback xmlns="">
           <p:sp>
             <p:nvSpPr>
               <p:cNvPr id="3" name="Content Placeholder 2">
@@ -13150,8 +13145,8 @@
           </a:p>
         </p:txBody>
       </p:sp>
-      <mc:AlternateContent xmlns:mc="http://schemas.openxmlformats.org/markup-compatibility/2006">
-        <mc:Choice xmlns:a14="http://schemas.microsoft.com/office/drawing/2010/main" Requires="a14">
+      <mc:AlternateContent xmlns:mc="http://schemas.openxmlformats.org/markup-compatibility/2006" xmlns:a14="http://schemas.microsoft.com/office/drawing/2010/main">
+        <mc:Choice Requires="a14">
           <p:sp>
             <p:nvSpPr>
               <p:cNvPr id="3" name="Content Placeholder 2">
@@ -13420,7 +13415,7 @@
             </p:txBody>
           </p:sp>
         </mc:Choice>
-        <mc:Fallback>
+        <mc:Fallback xmlns="">
           <p:sp>
             <p:nvSpPr>
               <p:cNvPr id="3" name="Content Placeholder 2">
@@ -18847,8 +18842,8 @@
           </a:p>
         </p:txBody>
       </p:sp>
-      <mc:AlternateContent xmlns:mc="http://schemas.openxmlformats.org/markup-compatibility/2006">
-        <mc:Choice xmlns:a14="http://schemas.microsoft.com/office/drawing/2010/main" Requires="a14">
+      <mc:AlternateContent xmlns:mc="http://schemas.openxmlformats.org/markup-compatibility/2006" xmlns:a14="http://schemas.microsoft.com/office/drawing/2010/main">
+        <mc:Choice Requires="a14">
           <p:sp>
             <p:nvSpPr>
               <p:cNvPr id="3" name="Content Placeholder 2">
@@ -19164,7 +19159,7 @@
             </p:txBody>
           </p:sp>
         </mc:Choice>
-        <mc:Fallback>
+        <mc:Fallback xmlns="">
           <p:sp>
             <p:nvSpPr>
               <p:cNvPr id="3" name="Content Placeholder 2">
@@ -21388,8 +21383,8 @@
           </a:p>
         </p:txBody>
       </p:sp>
-      <mc:AlternateContent xmlns:mc="http://schemas.openxmlformats.org/markup-compatibility/2006">
-        <mc:Choice xmlns:a14="http://schemas.microsoft.com/office/drawing/2010/main" Requires="a14">
+      <mc:AlternateContent xmlns:mc="http://schemas.openxmlformats.org/markup-compatibility/2006" xmlns:a14="http://schemas.microsoft.com/office/drawing/2010/main">
+        <mc:Choice Requires="a14">
           <p:sp>
             <p:nvSpPr>
               <p:cNvPr id="3" name="Content Placeholder 2">
@@ -21572,7 +21567,7 @@
             </p:txBody>
           </p:sp>
         </mc:Choice>
-        <mc:Fallback>
+        <mc:Fallback xmlns="">
           <p:sp>
             <p:nvSpPr>
               <p:cNvPr id="3" name="Content Placeholder 2">
@@ -22232,8 +22227,8 @@
           </a:p>
         </p:txBody>
       </p:sp>
-      <mc:AlternateContent xmlns:mc="http://schemas.openxmlformats.org/markup-compatibility/2006">
-        <mc:Choice xmlns:a14="http://schemas.microsoft.com/office/drawing/2010/main" Requires="a14">
+      <mc:AlternateContent xmlns:mc="http://schemas.openxmlformats.org/markup-compatibility/2006" xmlns:a14="http://schemas.microsoft.com/office/drawing/2010/main">
+        <mc:Choice Requires="a14">
           <p:sp>
             <p:nvSpPr>
               <p:cNvPr id="7" name="Rectangle 6">
@@ -22423,7 +22418,7 @@
             </p:txBody>
           </p:sp>
         </mc:Choice>
-        <mc:Fallback>
+        <mc:Fallback xmlns="">
           <p:sp>
             <p:nvSpPr>
               <p:cNvPr id="7" name="Rectangle 6">
@@ -22568,8 +22563,8 @@
           </a:p>
         </p:txBody>
       </p:sp>
-      <mc:AlternateContent xmlns:mc="http://schemas.openxmlformats.org/markup-compatibility/2006">
-        <mc:Choice xmlns:a14="http://schemas.microsoft.com/office/drawing/2010/main" Requires="a14">
+      <mc:AlternateContent xmlns:mc="http://schemas.openxmlformats.org/markup-compatibility/2006" xmlns:a14="http://schemas.microsoft.com/office/drawing/2010/main">
+        <mc:Choice Requires="a14">
           <p:sp>
             <p:nvSpPr>
               <p:cNvPr id="10" name="TextBox 9">
@@ -22604,6 +22599,7 @@
                 </a:r>
               </a:p>
               <a:p>
+                <a:pPr/>
                 <a14:m>
                   <m:oMathPara xmlns:m="http://schemas.openxmlformats.org/officeDocument/2006/math">
                     <m:oMathParaPr>
@@ -22680,7 +22676,7 @@
             </p:txBody>
           </p:sp>
         </mc:Choice>
-        <mc:Fallback>
+        <mc:Fallback xmlns="">
           <p:sp>
             <p:nvSpPr>
               <p:cNvPr id="10" name="TextBox 9">
@@ -24357,8 +24353,8 @@
           </a:p>
         </p:txBody>
       </p:sp>
-      <mc:AlternateContent xmlns:mc="http://schemas.openxmlformats.org/markup-compatibility/2006">
-        <mc:Choice xmlns:a14="http://schemas.microsoft.com/office/drawing/2010/main" Requires="a14">
+      <mc:AlternateContent xmlns:mc="http://schemas.openxmlformats.org/markup-compatibility/2006" xmlns:a14="http://schemas.microsoft.com/office/drawing/2010/main">
+        <mc:Choice Requires="a14">
           <p:sp>
             <p:nvSpPr>
               <p:cNvPr id="4" name="TextBox 3">
@@ -24895,7 +24891,7 @@
             </p:txBody>
           </p:sp>
         </mc:Choice>
-        <mc:Fallback>
+        <mc:Fallback xmlns="">
           <p:sp>
             <p:nvSpPr>
               <p:cNvPr id="4" name="TextBox 3">
@@ -26841,18 +26837,18 @@
 </file>
 
 <file path=customXml/item2.xml><?xml version="1.0" encoding="utf-8"?>
+<p:properties xmlns:p="http://schemas.microsoft.com/office/2006/metadata/properties" xmlns:xsi="http://www.w3.org/2001/XMLSchema-instance" xmlns:pc="http://schemas.microsoft.com/office/infopath/2007/PartnerControls">
+  <documentManagement/>
+</p:properties>
+</file>
+
+<file path=customXml/item3.xml><?xml version="1.0" encoding="utf-8"?>
 <?mso-contentType ?>
 <FormTemplates xmlns="http://schemas.microsoft.com/sharepoint/v3/contenttype/forms">
   <Display>DocumentLibraryForm</Display>
   <Edit>DocumentLibraryForm</Edit>
   <New>DocumentLibraryForm</New>
 </FormTemplates>
-</file>
-
-<file path=customXml/item3.xml><?xml version="1.0" encoding="utf-8"?>
-<p:properties xmlns:p="http://schemas.microsoft.com/office/2006/metadata/properties" xmlns:xsi="http://www.w3.org/2001/XMLSchema-instance" xmlns:pc="http://schemas.microsoft.com/office/infopath/2007/PartnerControls">
-  <documentManagement/>
-</p:properties>
 </file>
 
 <file path=customXml/itemProps1.xml><?xml version="1.0" encoding="utf-8"?>
@@ -26875,14 +26871,6 @@
 </file>
 
 <file path=customXml/itemProps2.xml><?xml version="1.0" encoding="utf-8"?>
-<ds:datastoreItem xmlns:ds="http://schemas.openxmlformats.org/officeDocument/2006/customXml" ds:itemID="{E49AC1EE-B6B3-4625-9CB8-D61F060C41FF}">
-  <ds:schemaRefs>
-    <ds:schemaRef ds:uri="http://schemas.microsoft.com/sharepoint/v3/contenttype/forms"/>
-  </ds:schemaRefs>
-</ds:datastoreItem>
-</file>
-
-<file path=customXml/itemProps3.xml><?xml version="1.0" encoding="utf-8"?>
 <ds:datastoreItem xmlns:ds="http://schemas.openxmlformats.org/officeDocument/2006/customXml" ds:itemID="{3B587AB4-D8C9-43A3-B80F-6729B49465FB}">
   <ds:schemaRefs>
     <ds:schemaRef ds:uri="http://purl.org/dc/elements/1.1/"/>
@@ -26897,4 +26885,12 @@
     <ds:schemaRef ds:uri="http://purl.org/dc/dcmitype/"/>
   </ds:schemaRefs>
 </ds:datastoreItem>
+</file>
+
+<file path=customXml/itemProps3.xml><?xml version="1.0" encoding="utf-8"?>
+<ds:datastoreItem xmlns:ds="http://schemas.openxmlformats.org/officeDocument/2006/customXml" ds:itemID="{E49AC1EE-B6B3-4625-9CB8-D61F060C41FF}">
+  <ds:schemaRefs>
+    <ds:schemaRef ds:uri="http://schemas.microsoft.com/sharepoint/v3/contenttype/forms"/>
+  </ds:schemaRefs>
+</ds:datastoreItem>
 </file>
</xml_diff>